<commit_message>
update week 4 slide content and corresponding presentation file
</commit_message>
<xml_diff>
--- a/Assignment/Week4/Slide/slides_Week4.pptx
+++ b/Assignment/Week4/Slide/slides_Week4.pptx
@@ -12,6 +12,7 @@
     <p:sldId id="260" r:id="rId11"/>
     <p:sldId id="261" r:id="rId12"/>
     <p:sldId id="262" r:id="rId13"/>
+    <p:sldId id="263" r:id="rId14"/>
   </p:sldIdLst>
   <p:sldSz cx="12191695" cy="6858000" type="screen4x3"/>
   <p:notesSz cx="6858000" cy="9144000"/>
@@ -3498,6 +3499,41 @@
           </a:p>
         </p:txBody>
       </p:sp>
+      <p:sp>
+        <p:nvSpPr>
+          <p:cNvPr id="12" name="TextBox 11"/>
+          <p:cNvSpPr txBox="1"/>
+          <p:nvPr/>
+        </p:nvSpPr>
+        <p:spPr>
+          <a:xfrm>
+            <a:off x="11082528" y="6428232"/>
+            <a:ext cx="530352" cy="256032"/>
+          </a:xfrm>
+          <a:prstGeom prst="rect">
+            <a:avLst/>
+          </a:prstGeom>
+          <a:noFill/>
+        </p:spPr>
+        <p:txBody>
+          <a:bodyPr wrap="square" lIns="0" rIns="0" tIns="0" bIns="0" anchor="t">
+            <a:spAutoFit/>
+          </a:bodyPr>
+          <a:lstStyle/>
+          <a:p>
+            <a:pPr algn="r"/>
+            <a:r>
+              <a:rPr sz="1200" b="1">
+                <a:solidFill>
+                  <a:srgbClr val="FFFFFF"/>
+                </a:solidFill>
+                <a:latin typeface="Arial"/>
+              </a:rPr>
+              <a:t>01</a:t>
+            </a:r>
+          </a:p>
+        </p:txBody>
+      </p:sp>
     </p:spTree>
   </p:cSld>
   <p:clrMapOvr>
@@ -4701,8 +4737,8 @@
         </p:nvSpPr>
         <p:spPr>
           <a:xfrm>
-            <a:off x="11082528" y="6455664"/>
-            <a:ext cx="530352" cy="201168"/>
+            <a:off x="11082528" y="6428232"/>
+            <a:ext cx="530352" cy="256032"/>
           </a:xfrm>
           <a:prstGeom prst="rect">
             <a:avLst/>
@@ -4717,13 +4753,13 @@
           <a:p>
             <a:pPr algn="r"/>
             <a:r>
-              <a:rPr sz="900" b="1">
+              <a:rPr sz="1200" b="1">
                 <a:solidFill>
                   <a:srgbClr val="6C757D"/>
                 </a:solidFill>
                 <a:latin typeface="Arial"/>
               </a:rPr>
-              <a:t>2</a:t>
+              <a:t>02</a:t>
             </a:r>
           </a:p>
         </p:txBody>
@@ -5710,8 +5746,8 @@
         </p:nvSpPr>
         <p:spPr>
           <a:xfrm>
-            <a:off x="11082528" y="6455664"/>
-            <a:ext cx="530352" cy="201168"/>
+            <a:off x="11082528" y="6428232"/>
+            <a:ext cx="530352" cy="256032"/>
           </a:xfrm>
           <a:prstGeom prst="rect">
             <a:avLst/>
@@ -5726,13 +5762,13 @@
           <a:p>
             <a:pPr algn="r"/>
             <a:r>
-              <a:rPr sz="900" b="1">
+              <a:rPr sz="1200" b="1">
                 <a:solidFill>
                   <a:srgbClr val="6C757D"/>
                 </a:solidFill>
                 <a:latin typeface="Arial"/>
               </a:rPr>
-              <a:t>3</a:t>
+              <a:t>03</a:t>
             </a:r>
           </a:p>
         </p:txBody>
@@ -5871,7 +5907,7 @@
                 </a:solidFill>
                 <a:latin typeface="Arial"/>
               </a:rPr>
-              <a:t>02  ผลการทดลอง</a:t>
+              <a:t>02  Numerical Results</a:t>
             </a:r>
           </a:p>
         </p:txBody>
@@ -5906,7 +5942,7 @@
                 </a:solidFill>
                 <a:latin typeface="Arial"/>
               </a:rPr>
-              <a:t>Bias / Variance / MSE ของตัวประมาณ</a:t>
+              <a:t>ตัวเลขจากการทดลอง: เปรียบเทียบวิธีวัดผล</a:t>
             </a:r>
           </a:p>
         </p:txBody>
@@ -5962,8 +5998,8 @@
         </p:nvSpPr>
         <p:spPr>
           <a:xfrm>
-            <a:off x="658368" y="1124712"/>
-            <a:ext cx="10972800" cy="274320"/>
+            <a:off x="658368" y="1143000"/>
+            <a:ext cx="10789920" cy="274320"/>
           </a:xfrm>
           <a:prstGeom prst="rect">
             <a:avLst/>
@@ -5984,35 +6020,391 @@
                 </a:solidFill>
                 <a:latin typeface="Arial"/>
               </a:rPr>
-              <a:t>Resubstitution มีแนวโน้มติดลบ เพราะประเมิน error ต่ำกว่าความจริง</a:t>
-            </a:r>
-          </a:p>
-        </p:txBody>
-      </p:sp>
-      <p:pic>
-        <p:nvPicPr>
-          <p:cNvPr id="8" name="Picture 7" descr="part2.png"/>
-          <p:cNvPicPr>
-            <a:picLocks noChangeAspect="1"/>
-          </p:cNvPicPr>
-          <p:nvPr/>
-        </p:nvPicPr>
-        <p:blipFill>
-          <a:blip r:embed="rId2"/>
-          <a:stretch>
-            <a:fillRect/>
-          </a:stretch>
-        </p:blipFill>
-        <p:spPr>
-          <a:xfrm>
-            <a:off x="566928" y="1498701"/>
-            <a:ext cx="11045952" cy="4418380"/>
-          </a:xfrm>
-          <a:prstGeom prst="rect">
-            <a:avLst/>
-          </a:prstGeom>
-        </p:spPr>
-      </p:pic>
+              <a:t>ผลจากข้อมูลชุดเดียวที่ n = 20 และ σ = 0.3 — ค่าทั้งหมดมาจากโค้ด Week4</a:t>
+            </a:r>
+          </a:p>
+        </p:txBody>
+      </p:sp>
+      <p:graphicFrame>
+        <p:nvGraphicFramePr>
+          <p:cNvPr id="8" name="Table 7"/>
+          <p:cNvGraphicFramePr>
+            <a:graphicFrameLocks noGrp="1"/>
+          </p:cNvGraphicFramePr>
+          <p:nvPr/>
+        </p:nvGraphicFramePr>
+        <p:xfrm>
+          <a:off x="566928" y="1536192"/>
+          <a:ext cx="11045952" cy="1828800"/>
+        </p:xfrm>
+        <a:graphic>
+          <a:graphicData uri="http://schemas.openxmlformats.org/drawingml/2006/table">
+            <a:tbl>
+              <a:tblPr firstRow="1" bandRow="1">
+                <a:tableStyleId>{5C22544A-7EE6-4342-B048-85BDC9FD1C3A}</a:tableStyleId>
+              </a:tblPr>
+              <a:tblGrid>
+                <a:gridCol w="2331720"/>
+                <a:gridCol w="2148840"/>
+                <a:gridCol w="2331720"/>
+                <a:gridCol w="2057400"/>
+                <a:gridCol w="2176272"/>
+              </a:tblGrid>
+              <a:tr h="609600">
+                <a:tc>
+                  <a:txBody>
+                    <a:bodyPr/>
+                    <a:lstStyle/>
+                    <a:p>
+                      <a:pPr algn="l"/>
+                      <a:r>
+                        <a:rPr sz="1200" b="1">
+                          <a:solidFill>
+                            <a:srgbClr val="FFFFFF"/>
+                          </a:solidFill>
+                          <a:latin typeface="Arial"/>
+                        </a:rPr>
+                        <a:t>โมเดล</a:t>
+                      </a:r>
+                    </a:p>
+                  </a:txBody>
+                  <a:tcPr anchor="ctr" marL="54864" marR="54864" marT="18288" marB="18288">
+                    <a:solidFill>
+                      <a:srgbClr val="2D6A4F"/>
+                    </a:solidFill>
+                  </a:tcPr>
+                </a:tc>
+                <a:tc>
+                  <a:txBody>
+                    <a:bodyPr/>
+                    <a:lstStyle/>
+                    <a:p>
+                      <a:pPr algn="ctr"/>
+                      <a:r>
+                        <a:rPr sz="1200" b="1">
+                          <a:solidFill>
+                            <a:srgbClr val="FFFFFF"/>
+                          </a:solidFill>
+                          <a:latin typeface="Arial"/>
+                        </a:rPr>
+                        <a:t>true Eout</a:t>
+                      </a:r>
+                    </a:p>
+                  </a:txBody>
+                  <a:tcPr anchor="ctr" marL="54864" marR="54864" marT="18288" marB="18288">
+                    <a:solidFill>
+                      <a:srgbClr val="2D6A4F"/>
+                    </a:solidFill>
+                  </a:tcPr>
+                </a:tc>
+                <a:tc>
+                  <a:txBody>
+                    <a:bodyPr/>
+                    <a:lstStyle/>
+                    <a:p>
+                      <a:pPr algn="ctr"/>
+                      <a:r>
+                        <a:rPr sz="1200" b="1">
+                          <a:solidFill>
+                            <a:srgbClr val="FFFFFF"/>
+                          </a:solidFill>
+                          <a:latin typeface="Arial"/>
+                        </a:rPr>
+                        <a:t>Resubstitution</a:t>
+                      </a:r>
+                    </a:p>
+                  </a:txBody>
+                  <a:tcPr anchor="ctr" marL="54864" marR="54864" marT="18288" marB="18288">
+                    <a:solidFill>
+                      <a:srgbClr val="2D6A4F"/>
+                    </a:solidFill>
+                  </a:tcPr>
+                </a:tc>
+                <a:tc>
+                  <a:txBody>
+                    <a:bodyPr/>
+                    <a:lstStyle/>
+                    <a:p>
+                      <a:pPr algn="ctr"/>
+                      <a:r>
+                        <a:rPr sz="1200" b="1">
+                          <a:solidFill>
+                            <a:srgbClr val="FFFFFF"/>
+                          </a:solidFill>
+                          <a:latin typeface="Arial"/>
+                        </a:rPr>
+                        <a:t>Holdout 70%</a:t>
+                      </a:r>
+                    </a:p>
+                  </a:txBody>
+                  <a:tcPr anchor="ctr" marL="54864" marR="54864" marT="18288" marB="18288">
+                    <a:solidFill>
+                      <a:srgbClr val="2D6A4F"/>
+                    </a:solidFill>
+                  </a:tcPr>
+                </a:tc>
+                <a:tc>
+                  <a:txBody>
+                    <a:bodyPr/>
+                    <a:lstStyle/>
+                    <a:p>
+                      <a:pPr algn="ctr"/>
+                      <a:r>
+                        <a:rPr sz="1200" b="1">
+                          <a:solidFill>
+                            <a:srgbClr val="FFFFFF"/>
+                          </a:solidFill>
+                          <a:latin typeface="Arial"/>
+                        </a:rPr>
+                        <a:t>5-Fold CV</a:t>
+                      </a:r>
+                    </a:p>
+                  </a:txBody>
+                  <a:tcPr anchor="ctr" marL="54864" marR="54864" marT="18288" marB="18288">
+                    <a:solidFill>
+                      <a:srgbClr val="2D6A4F"/>
+                    </a:solidFill>
+                  </a:tcPr>
+                </a:tc>
+              </a:tr>
+              <a:tr h="609600">
+                <a:tc>
+                  <a:txBody>
+                    <a:bodyPr/>
+                    <a:lstStyle/>
+                    <a:p>
+                      <a:pPr algn="l"/>
+                      <a:r>
+                        <a:rPr sz="1300" b="0">
+                          <a:solidFill>
+                            <a:srgbClr val="212529"/>
+                          </a:solidFill>
+                          <a:latin typeface="Arial"/>
+                        </a:rPr>
+                        <a:t>Constant</a:t>
+                      </a:r>
+                    </a:p>
+                  </a:txBody>
+                  <a:tcPr anchor="ctr" marL="54864" marR="54864" marT="18288" marB="18288">
+                    <a:solidFill>
+                      <a:srgbClr val="FFFFFF"/>
+                    </a:solidFill>
+                  </a:tcPr>
+                </a:tc>
+                <a:tc>
+                  <a:txBody>
+                    <a:bodyPr/>
+                    <a:lstStyle/>
+                    <a:p>
+                      <a:pPr algn="ctr"/>
+                      <a:r>
+                        <a:rPr sz="1300" b="0">
+                          <a:solidFill>
+                            <a:srgbClr val="212529"/>
+                          </a:solidFill>
+                          <a:latin typeface="Arial"/>
+                        </a:rPr>
+                        <a:t>0.6343</a:t>
+                      </a:r>
+                    </a:p>
+                  </a:txBody>
+                  <a:tcPr anchor="ctr" marL="54864" marR="54864" marT="18288" marB="18288">
+                    <a:solidFill>
+                      <a:srgbClr val="FFFFFF"/>
+                    </a:solidFill>
+                  </a:tcPr>
+                </a:tc>
+                <a:tc>
+                  <a:txBody>
+                    <a:bodyPr/>
+                    <a:lstStyle/>
+                    <a:p>
+                      <a:pPr algn="ctr"/>
+                      <a:r>
+                        <a:rPr sz="1300" b="0">
+                          <a:solidFill>
+                            <a:srgbClr val="212529"/>
+                          </a:solidFill>
+                          <a:latin typeface="Arial"/>
+                        </a:rPr>
+                        <a:t>0.4577</a:t>
+                      </a:r>
+                    </a:p>
+                  </a:txBody>
+                  <a:tcPr anchor="ctr" marL="54864" marR="54864" marT="18288" marB="18288">
+                    <a:solidFill>
+                      <a:srgbClr val="FFFFFF"/>
+                    </a:solidFill>
+                  </a:tcPr>
+                </a:tc>
+                <a:tc>
+                  <a:txBody>
+                    <a:bodyPr/>
+                    <a:lstStyle/>
+                    <a:p>
+                      <a:pPr algn="ctr"/>
+                      <a:r>
+                        <a:rPr sz="1300" b="0">
+                          <a:solidFill>
+                            <a:srgbClr val="212529"/>
+                          </a:solidFill>
+                          <a:latin typeface="Arial"/>
+                        </a:rPr>
+                        <a:t>0.7149</a:t>
+                      </a:r>
+                    </a:p>
+                  </a:txBody>
+                  <a:tcPr anchor="ctr" marL="54864" marR="54864" marT="18288" marB="18288">
+                    <a:solidFill>
+                      <a:srgbClr val="FFFFFF"/>
+                    </a:solidFill>
+                  </a:tcPr>
+                </a:tc>
+                <a:tc>
+                  <a:txBody>
+                    <a:bodyPr/>
+                    <a:lstStyle/>
+                    <a:p>
+                      <a:pPr algn="ctr"/>
+                      <a:r>
+                        <a:rPr sz="1300" b="0">
+                          <a:solidFill>
+                            <a:srgbClr val="212529"/>
+                          </a:solidFill>
+                          <a:latin typeface="Arial"/>
+                        </a:rPr>
+                        <a:t>0.5067</a:t>
+                      </a:r>
+                    </a:p>
+                  </a:txBody>
+                  <a:tcPr anchor="ctr" marL="54864" marR="54864" marT="18288" marB="18288">
+                    <a:solidFill>
+                      <a:srgbClr val="FFFFFF"/>
+                    </a:solidFill>
+                  </a:tcPr>
+                </a:tc>
+              </a:tr>
+              <a:tr h="609600">
+                <a:tc>
+                  <a:txBody>
+                    <a:bodyPr/>
+                    <a:lstStyle/>
+                    <a:p>
+                      <a:pPr algn="l"/>
+                      <a:r>
+                        <a:rPr sz="1300" b="0">
+                          <a:solidFill>
+                            <a:srgbClr val="212529"/>
+                          </a:solidFill>
+                          <a:latin typeface="Arial"/>
+                        </a:rPr>
+                        <a:t>Linear</a:t>
+                      </a:r>
+                    </a:p>
+                  </a:txBody>
+                  <a:tcPr anchor="ctr" marL="54864" marR="54864" marT="18288" marB="18288">
+                    <a:solidFill>
+                      <a:srgbClr val="E9ECEF"/>
+                    </a:solidFill>
+                  </a:tcPr>
+                </a:tc>
+                <a:tc>
+                  <a:txBody>
+                    <a:bodyPr/>
+                    <a:lstStyle/>
+                    <a:p>
+                      <a:pPr algn="ctr"/>
+                      <a:r>
+                        <a:rPr sz="1300" b="0">
+                          <a:solidFill>
+                            <a:srgbClr val="212529"/>
+                          </a:solidFill>
+                          <a:latin typeface="Arial"/>
+                        </a:rPr>
+                        <a:t>0.3003</a:t>
+                      </a:r>
+                    </a:p>
+                  </a:txBody>
+                  <a:tcPr anchor="ctr" marL="54864" marR="54864" marT="18288" marB="18288">
+                    <a:solidFill>
+                      <a:srgbClr val="E9ECEF"/>
+                    </a:solidFill>
+                  </a:tcPr>
+                </a:tc>
+                <a:tc>
+                  <a:txBody>
+                    <a:bodyPr/>
+                    <a:lstStyle/>
+                    <a:p>
+                      <a:pPr algn="ctr"/>
+                      <a:r>
+                        <a:rPr sz="1300" b="0">
+                          <a:solidFill>
+                            <a:srgbClr val="212529"/>
+                          </a:solidFill>
+                          <a:latin typeface="Arial"/>
+                        </a:rPr>
+                        <a:t>0.3066</a:t>
+                      </a:r>
+                    </a:p>
+                  </a:txBody>
+                  <a:tcPr anchor="ctr" marL="54864" marR="54864" marT="18288" marB="18288">
+                    <a:solidFill>
+                      <a:srgbClr val="E9ECEF"/>
+                    </a:solidFill>
+                  </a:tcPr>
+                </a:tc>
+                <a:tc>
+                  <a:txBody>
+                    <a:bodyPr/>
+                    <a:lstStyle/>
+                    <a:p>
+                      <a:pPr algn="ctr"/>
+                      <a:r>
+                        <a:rPr sz="1300" b="0">
+                          <a:solidFill>
+                            <a:srgbClr val="212529"/>
+                          </a:solidFill>
+                          <a:latin typeface="Arial"/>
+                        </a:rPr>
+                        <a:t>0.5889</a:t>
+                      </a:r>
+                    </a:p>
+                  </a:txBody>
+                  <a:tcPr anchor="ctr" marL="54864" marR="54864" marT="18288" marB="18288">
+                    <a:solidFill>
+                      <a:srgbClr val="E9ECEF"/>
+                    </a:solidFill>
+                  </a:tcPr>
+                </a:tc>
+                <a:tc>
+                  <a:txBody>
+                    <a:bodyPr/>
+                    <a:lstStyle/>
+                    <a:p>
+                      <a:pPr algn="ctr"/>
+                      <a:r>
+                        <a:rPr sz="1300" b="0">
+                          <a:solidFill>
+                            <a:srgbClr val="212529"/>
+                          </a:solidFill>
+                          <a:latin typeface="Arial"/>
+                        </a:rPr>
+                        <a:t>0.3905</a:t>
+                      </a:r>
+                    </a:p>
+                  </a:txBody>
+                  <a:tcPr anchor="ctr" marL="54864" marR="54864" marT="18288" marB="18288">
+                    <a:solidFill>
+                      <a:srgbClr val="E9ECEF"/>
+                    </a:solidFill>
+                  </a:tcPr>
+                </a:tc>
+              </a:tr>
+            </a:tbl>
+          </a:graphicData>
+        </a:graphic>
+      </p:graphicFrame>
       <p:sp>
         <p:nvSpPr>
           <p:cNvPr id="9" name="TextBox 8"/>
@@ -6021,8 +6413,8 @@
         </p:nvSpPr>
         <p:spPr>
           <a:xfrm>
-            <a:off x="658368" y="6108192"/>
-            <a:ext cx="10881360" cy="228600"/>
+            <a:off x="566928" y="3822191"/>
+            <a:ext cx="2926080" cy="274320"/>
           </a:xfrm>
           <a:prstGeom prst="rect">
             <a:avLst/>
@@ -6035,7 +6427,130 @@
           </a:bodyPr>
           <a:lstStyle/>
           <a:p>
+            <a:pPr algn="l"/>
+            <a:r>
+              <a:rPr sz="1800" b="1">
+                <a:solidFill>
+                  <a:srgbClr val="212529"/>
+                </a:solidFill>
+                <a:latin typeface="Arial"/>
+              </a:rPr>
+              <a:t>ข้อสังเกต</a:t>
+            </a:r>
+          </a:p>
+        </p:txBody>
+      </p:sp>
+      <p:sp>
+        <p:nvSpPr>
+          <p:cNvPr id="10" name="Rectangle 9"/>
+          <p:cNvSpPr/>
+          <p:nvPr/>
+        </p:nvSpPr>
+        <p:spPr>
+          <a:xfrm>
+            <a:off x="566928" y="4187952"/>
+            <a:ext cx="54864" cy="1024128"/>
+          </a:xfrm>
+          <a:prstGeom prst="rect">
+            <a:avLst/>
+          </a:prstGeom>
+          <a:solidFill>
+            <a:srgbClr val="D62828"/>
+          </a:solidFill>
+          <a:ln>
+            <a:noFill/>
+          </a:ln>
+        </p:spPr>
+        <p:style>
+          <a:lnRef idx="1">
+            <a:schemeClr val="accent1"/>
+          </a:lnRef>
+          <a:fillRef idx="3">
+            <a:schemeClr val="accent1"/>
+          </a:fillRef>
+          <a:effectRef idx="2">
+            <a:schemeClr val="accent1"/>
+          </a:effectRef>
+          <a:fontRef idx="minor">
+            <a:schemeClr val="lt1"/>
+          </a:fontRef>
+        </p:style>
+        <p:txBody>
+          <a:bodyPr rtlCol="0" anchor="ctr"/>
+          <a:lstStyle/>
+          <a:p>
             <a:pPr algn="ctr"/>
+          </a:p>
+        </p:txBody>
+      </p:sp>
+      <p:sp>
+        <p:nvSpPr>
+          <p:cNvPr id="11" name="TextBox 10"/>
+          <p:cNvSpPr txBox="1"/>
+          <p:nvPr/>
+        </p:nvSpPr>
+        <p:spPr>
+          <a:xfrm>
+            <a:off x="822960" y="4197096"/>
+            <a:ext cx="10561320" cy="804672"/>
+          </a:xfrm>
+          <a:prstGeom prst="rect">
+            <a:avLst/>
+          </a:prstGeom>
+          <a:noFill/>
+        </p:spPr>
+        <p:txBody>
+          <a:bodyPr wrap="square" lIns="0" rIns="0" tIns="0" bIns="0" anchor="t">
+            <a:spAutoFit/>
+          </a:bodyPr>
+          <a:lstStyle/>
+          <a:p>
+            <a:pPr algn="l"/>
+            <a:r>
+              <a:rPr sz="1600" b="0">
+                <a:solidFill>
+                  <a:srgbClr val="212529"/>
+                </a:solidFill>
+                <a:latin typeface="Arial"/>
+              </a:rPr>
+              <a:t>Resubstitution มีแนวโน้มประเมิน error ต่ำกว่าค่า true Eout เพราะใช้ข้อมูลชุดฝึกเดิมในการทดสอบ</a:t>
+            </a:r>
+            <a:br/>
+            <a:r>
+              <a:rPr sz="1600" b="0">
+                <a:solidFill>
+                  <a:srgbClr val="212529"/>
+                </a:solidFill>
+                <a:latin typeface="Arial"/>
+              </a:rPr>
+              <a:t>ส่วน Holdout แปรผันตามการแบ่งข้อมูล และ K-Fold ใช้ข้อมูลได้คุ้มกว่าด้วยการสลับ validation fold</a:t>
+            </a:r>
+          </a:p>
+        </p:txBody>
+      </p:sp>
+      <p:sp>
+        <p:nvSpPr>
+          <p:cNvPr id="12" name="TextBox 11"/>
+          <p:cNvSpPr txBox="1"/>
+          <p:nvPr/>
+        </p:nvSpPr>
+        <p:spPr>
+          <a:xfrm>
+            <a:off x="566928" y="5733288"/>
+            <a:ext cx="10972800" cy="274320"/>
+          </a:xfrm>
+          <a:prstGeom prst="rect">
+            <a:avLst/>
+          </a:prstGeom>
+          <a:noFill/>
+        </p:spPr>
+        <p:txBody>
+          <a:bodyPr wrap="square" lIns="0" rIns="0" tIns="0" bIns="0" anchor="t">
+            <a:spAutoFit/>
+          </a:bodyPr>
+          <a:lstStyle/>
+          <a:p>
+            <a:pPr algn="l"/>
             <a:r>
               <a:rPr sz="1000" b="0">
                 <a:solidFill>
@@ -6043,14 +6558,14 @@
                 </a:solidFill>
                 <a:latin typeface="Arial"/>
               </a:rPr>
-              <a:t>แกนตั้ง = estimate − true Eout  |  เส้นดำ = 0  |  สามเหลี่ยมสีเขียว = ค่าเฉลี่ย</a:t>
-            </a:r>
-          </a:p>
-        </p:txBody>
-      </p:sp>
-      <p:sp>
-        <p:nvSpPr>
-          <p:cNvPr id="10" name="Rectangle 9"/>
+              <a:t>หมายเหตุ: ตารางนี้ไม่มีการคำนวณมือ — ใช้ค่าจาก single dataset ใน HW2.py โดยตรง</a:t>
+            </a:r>
+          </a:p>
+        </p:txBody>
+      </p:sp>
+      <p:sp>
+        <p:nvSpPr>
+          <p:cNvPr id="13" name="Rectangle 12"/>
           <p:cNvSpPr/>
           <p:nvPr/>
         </p:nvSpPr>
@@ -6093,7 +6608,7 @@
       </p:sp>
       <p:sp>
         <p:nvSpPr>
-          <p:cNvPr id="11" name="TextBox 10"/>
+          <p:cNvPr id="14" name="TextBox 13"/>
           <p:cNvSpPr txBox="1"/>
           <p:nvPr/>
         </p:nvSpPr>
@@ -6128,14 +6643,14 @@
       </p:sp>
       <p:sp>
         <p:nvSpPr>
-          <p:cNvPr id="12" name="TextBox 11"/>
+          <p:cNvPr id="15" name="TextBox 14"/>
           <p:cNvSpPr txBox="1"/>
           <p:nvPr/>
         </p:nvSpPr>
         <p:spPr>
           <a:xfrm>
-            <a:off x="11082528" y="6455664"/>
-            <a:ext cx="530352" cy="201168"/>
+            <a:off x="11082528" y="6428232"/>
+            <a:ext cx="530352" cy="256032"/>
           </a:xfrm>
           <a:prstGeom prst="rect">
             <a:avLst/>
@@ -6150,13 +6665,13 @@
           <a:p>
             <a:pPr algn="r"/>
             <a:r>
-              <a:rPr sz="900" b="1">
+              <a:rPr sz="1200" b="1">
                 <a:solidFill>
                   <a:srgbClr val="6C757D"/>
                 </a:solidFill>
                 <a:latin typeface="Arial"/>
               </a:rPr>
-              <a:t>4</a:t>
+              <a:t>04</a:t>
             </a:r>
           </a:p>
         </p:txBody>
@@ -6295,7 +6810,7 @@
                 </a:solidFill>
                 <a:latin typeface="Arial"/>
               </a:rPr>
-              <a:t>03  Sensitivity Analysis</a:t>
+              <a:t>02  ผลการทดลอง</a:t>
             </a:r>
           </a:p>
         </p:txBody>
@@ -6330,7 +6845,7 @@
                 </a:solidFill>
                 <a:latin typeface="Arial"/>
               </a:rPr>
-              <a:t>ผลของสัดส่วน Holdout และจำนวน fold</a:t>
+              <a:t>Bias / Variance / MSE ของตัวประมาณ</a:t>
             </a:r>
           </a:p>
         </p:txBody>
@@ -6408,14 +6923,14 @@
                 </a:solidFill>
                 <a:latin typeface="Arial"/>
               </a:rPr>
-              <a:t>Holdout ที่ใช้ข้อมูลฝึกน้อยเกินไปมี variance สูงมาก ส่วน K-Fold นิ่งขึ้นเมื่อ k เพิ่ม</a:t>
+              <a:t>Resubstitution มีแนวโน้มติดลบ เพราะประเมิน error ต่ำกว่าความจริง</a:t>
             </a:r>
           </a:p>
         </p:txBody>
       </p:sp>
       <p:pic>
         <p:nvPicPr>
-          <p:cNvPr id="8" name="Picture 7" descr="part3.png"/>
+          <p:cNvPr id="8" name="Picture 7" descr="part2.png"/>
           <p:cNvPicPr>
             <a:picLocks noChangeAspect="1"/>
           </p:cNvPicPr>
@@ -6429,8 +6944,8 @@
         </p:blipFill>
         <p:spPr>
           <a:xfrm>
-            <a:off x="812509" y="1399032"/>
-            <a:ext cx="10554788" cy="4617720"/>
+            <a:off x="566928" y="1498701"/>
+            <a:ext cx="11045952" cy="4418380"/>
           </a:xfrm>
           <a:prstGeom prst="rect">
             <a:avLst/>
@@ -6467,7 +6982,7 @@
                 </a:solidFill>
                 <a:latin typeface="Arial"/>
               </a:rPr>
-              <a:t>ซ้าย: เปลี่ยนสัดส่วน train ของ Holdout  |  ขวา: เปลี่ยน k ของ K-Fold  |  ค่าที่ต่ำกว่ามักหมายถึง variance น้อยกว่า</a:t>
+              <a:t>แกนตั้ง = estimate − true Eout  |  เส้นดำ = 0  |  สามเหลี่ยมสีเขียว = ค่าเฉลี่ย</a:t>
             </a:r>
           </a:p>
         </p:txBody>
@@ -6558,8 +7073,8 @@
         </p:nvSpPr>
         <p:spPr>
           <a:xfrm>
-            <a:off x="11082528" y="6455664"/>
-            <a:ext cx="530352" cy="201168"/>
+            <a:off x="11082528" y="6428232"/>
+            <a:ext cx="530352" cy="256032"/>
           </a:xfrm>
           <a:prstGeom prst="rect">
             <a:avLst/>
@@ -6574,13 +7089,13 @@
           <a:p>
             <a:pPr algn="r"/>
             <a:r>
-              <a:rPr sz="900" b="1">
+              <a:rPr sz="1200" b="1">
                 <a:solidFill>
                   <a:srgbClr val="6C757D"/>
                 </a:solidFill>
                 <a:latin typeface="Arial"/>
               </a:rPr>
-              <a:t>5</a:t>
+              <a:t>05</a:t>
             </a:r>
           </a:p>
         </p:txBody>
@@ -6754,7 +7269,7 @@
                 </a:solidFill>
                 <a:latin typeface="Arial"/>
               </a:rPr>
-              <a:t>ผลของจำนวนข้อมูลและระดับ Noise</a:t>
+              <a:t>ผลของสัดส่วน Holdout และจำนวน fold</a:t>
             </a:r>
           </a:p>
         </p:txBody>
@@ -6832,14 +7347,14 @@
                 </a:solidFill>
                 <a:latin typeface="Arial"/>
               </a:rPr>
-              <a:t>เมื่อ n เพิ่ม variance ลดลง; เมื่อ σ เพิ่ม variance สูงขึ้น โดย Holdout และ Linear ได้รับผลชัดที่สุด</a:t>
+              <a:t>Holdout ที่ใช้ข้อมูลฝึกน้อยเกินไปมี variance สูงมาก ส่วน K-Fold นิ่งขึ้นเมื่อ k เพิ่ม</a:t>
             </a:r>
           </a:p>
         </p:txBody>
       </p:sp>
       <p:pic>
         <p:nvPicPr>
-          <p:cNvPr id="8" name="Picture 7" descr="part4.png"/>
+          <p:cNvPr id="8" name="Picture 7" descr="part3.png"/>
           <p:cNvPicPr>
             <a:picLocks noChangeAspect="1"/>
           </p:cNvPicPr>
@@ -6853,8 +7368,8 @@
         </p:blipFill>
         <p:spPr>
           <a:xfrm>
-            <a:off x="566928" y="1560068"/>
-            <a:ext cx="11045952" cy="4295648"/>
+            <a:off x="812509" y="1399032"/>
+            <a:ext cx="10554788" cy="4617720"/>
           </a:xfrm>
           <a:prstGeom prst="rect">
             <a:avLst/>
@@ -6891,7 +7406,7 @@
                 </a:solidFill>
                 <a:latin typeface="Arial"/>
               </a:rPr>
-              <a:t>แถวบน = Constant  |  แถวล่าง = Linear  |  น้ำเงิน = Resub  |  ส้ม = Holdout  |  เขียว = K-Fold</a:t>
+              <a:t>ซ้าย: เปลี่ยนสัดส่วน train ของ Holdout  |  ขวา: เปลี่ยน k ของ K-Fold  |  ค่าที่ต่ำกว่ามักหมายถึง variance น้อยกว่า</a:t>
             </a:r>
           </a:p>
         </p:txBody>
@@ -6982,8 +7497,8 @@
         </p:nvSpPr>
         <p:spPr>
           <a:xfrm>
-            <a:off x="11082528" y="6455664"/>
-            <a:ext cx="530352" cy="201168"/>
+            <a:off x="11082528" y="6428232"/>
+            <a:ext cx="530352" cy="256032"/>
           </a:xfrm>
           <a:prstGeom prst="rect">
             <a:avLst/>
@@ -6998,13 +7513,13 @@
           <a:p>
             <a:pPr algn="r"/>
             <a:r>
-              <a:rPr sz="900" b="1">
+              <a:rPr sz="1200" b="1">
                 <a:solidFill>
                   <a:srgbClr val="6C757D"/>
                 </a:solidFill>
                 <a:latin typeface="Arial"/>
               </a:rPr>
-              <a:t>6</a:t>
+              <a:t>06</a:t>
             </a:r>
           </a:p>
         </p:txBody>
@@ -7143,7 +7658,7 @@
                 </a:solidFill>
                 <a:latin typeface="Arial"/>
               </a:rPr>
-              <a:t>04  Conclusion</a:t>
+              <a:t>03  Sensitivity Analysis</a:t>
             </a:r>
           </a:p>
         </p:txBody>
@@ -7178,7 +7693,7 @@
                 </a:solidFill>
                 <a:latin typeface="Arial"/>
               </a:rPr>
-              <a:t>สรุป: เลือกวิธีวัดผลให้เหมาะกับข้อมูล</a:t>
+              <a:t>ผลของจำนวนข้อมูลและระดับ Noise</a:t>
             </a:r>
           </a:p>
         </p:txBody>
@@ -7228,14 +7743,239 @@
       </p:sp>
       <p:sp>
         <p:nvSpPr>
-          <p:cNvPr id="7" name="Rectangle 6"/>
+          <p:cNvPr id="7" name="TextBox 6"/>
+          <p:cNvSpPr txBox="1"/>
+          <p:nvPr/>
+        </p:nvSpPr>
+        <p:spPr>
+          <a:xfrm>
+            <a:off x="658368" y="1124712"/>
+            <a:ext cx="10972800" cy="274320"/>
+          </a:xfrm>
+          <a:prstGeom prst="rect">
+            <a:avLst/>
+          </a:prstGeom>
+          <a:noFill/>
+        </p:spPr>
+        <p:txBody>
+          <a:bodyPr wrap="square" lIns="0" rIns="0" tIns="0" bIns="0" anchor="t">
+            <a:spAutoFit/>
+          </a:bodyPr>
+          <a:lstStyle/>
+          <a:p>
+            <a:pPr algn="l"/>
+            <a:r>
+              <a:rPr sz="1300" b="0">
+                <a:solidFill>
+                  <a:srgbClr val="6C757D"/>
+                </a:solidFill>
+                <a:latin typeface="Arial"/>
+              </a:rPr>
+              <a:t>เมื่อ n เพิ่ม variance ลดลง; เมื่อ σ เพิ่ม variance สูงขึ้น โดย Holdout และ Linear ได้รับผลชัดที่สุด</a:t>
+            </a:r>
+          </a:p>
+        </p:txBody>
+      </p:sp>
+      <p:pic>
+        <p:nvPicPr>
+          <p:cNvPr id="8" name="Picture 7" descr="part4.png"/>
+          <p:cNvPicPr>
+            <a:picLocks noChangeAspect="1"/>
+          </p:cNvPicPr>
+          <p:nvPr/>
+        </p:nvPicPr>
+        <p:blipFill>
+          <a:blip r:embed="rId2"/>
+          <a:stretch>
+            <a:fillRect/>
+          </a:stretch>
+        </p:blipFill>
+        <p:spPr>
+          <a:xfrm>
+            <a:off x="566928" y="1560068"/>
+            <a:ext cx="11045952" cy="4295648"/>
+          </a:xfrm>
+          <a:prstGeom prst="rect">
+            <a:avLst/>
+          </a:prstGeom>
+        </p:spPr>
+      </p:pic>
+      <p:sp>
+        <p:nvSpPr>
+          <p:cNvPr id="9" name="TextBox 8"/>
+          <p:cNvSpPr txBox="1"/>
+          <p:nvPr/>
+        </p:nvSpPr>
+        <p:spPr>
+          <a:xfrm>
+            <a:off x="658368" y="6108192"/>
+            <a:ext cx="10881360" cy="228600"/>
+          </a:xfrm>
+          <a:prstGeom prst="rect">
+            <a:avLst/>
+          </a:prstGeom>
+          <a:noFill/>
+        </p:spPr>
+        <p:txBody>
+          <a:bodyPr wrap="square" lIns="0" rIns="0" tIns="0" bIns="0" anchor="t">
+            <a:spAutoFit/>
+          </a:bodyPr>
+          <a:lstStyle/>
+          <a:p>
+            <a:pPr algn="ctr"/>
+            <a:r>
+              <a:rPr sz="1000" b="0">
+                <a:solidFill>
+                  <a:srgbClr val="6C757D"/>
+                </a:solidFill>
+                <a:latin typeface="Arial"/>
+              </a:rPr>
+              <a:t>แถวบน = Constant  |  แถวล่าง = Linear  |  น้ำเงิน = Resub  |  ส้ม = Holdout  |  เขียว = K-Fold</a:t>
+            </a:r>
+          </a:p>
+        </p:txBody>
+      </p:sp>
+      <p:sp>
+        <p:nvSpPr>
+          <p:cNvPr id="10" name="Rectangle 9"/>
           <p:cNvSpPr/>
           <p:nvPr/>
         </p:nvSpPr>
         <p:spPr>
           <a:xfrm>
-            <a:off x="658368" y="1298448"/>
-            <a:ext cx="3401568" cy="3063240"/>
+            <a:off x="566928" y="6382512"/>
+            <a:ext cx="11045952" cy="10972"/>
+          </a:xfrm>
+          <a:prstGeom prst="rect">
+            <a:avLst/>
+          </a:prstGeom>
+          <a:solidFill>
+            <a:srgbClr val="DEE2E6"/>
+          </a:solidFill>
+          <a:ln>
+            <a:noFill/>
+          </a:ln>
+        </p:spPr>
+        <p:style>
+          <a:lnRef idx="1">
+            <a:schemeClr val="accent1"/>
+          </a:lnRef>
+          <a:fillRef idx="3">
+            <a:schemeClr val="accent1"/>
+          </a:fillRef>
+          <a:effectRef idx="2">
+            <a:schemeClr val="accent1"/>
+          </a:effectRef>
+          <a:fontRef idx="minor">
+            <a:schemeClr val="lt1"/>
+          </a:fontRef>
+        </p:style>
+        <p:txBody>
+          <a:bodyPr rtlCol="0" anchor="ctr"/>
+          <a:lstStyle/>
+          <a:p>
+            <a:pPr algn="ctr"/>
+          </a:p>
+        </p:txBody>
+      </p:sp>
+      <p:sp>
+        <p:nvSpPr>
+          <p:cNvPr id="11" name="TextBox 10"/>
+          <p:cNvSpPr txBox="1"/>
+          <p:nvPr/>
+        </p:nvSpPr>
+        <p:spPr>
+          <a:xfrm>
+            <a:off x="566928" y="6473952"/>
+            <a:ext cx="7772400" cy="182880"/>
+          </a:xfrm>
+          <a:prstGeom prst="rect">
+            <a:avLst/>
+          </a:prstGeom>
+          <a:noFill/>
+        </p:spPr>
+        <p:txBody>
+          <a:bodyPr wrap="square" lIns="0" rIns="0" tIns="0" bIns="0" anchor="t">
+            <a:spAutoFit/>
+          </a:bodyPr>
+          <a:lstStyle/>
+          <a:p>
+            <a:pPr algn="l"/>
+            <a:r>
+              <a:rPr sz="800" b="0">
+                <a:solidFill>
+                  <a:srgbClr val="6C757D"/>
+                </a:solidFill>
+                <a:latin typeface="Arial"/>
+              </a:rPr>
+              <a:t>Machine Learning — Week 4  |  Performance Estimation</a:t>
+            </a:r>
+          </a:p>
+        </p:txBody>
+      </p:sp>
+      <p:sp>
+        <p:nvSpPr>
+          <p:cNvPr id="12" name="TextBox 11"/>
+          <p:cNvSpPr txBox="1"/>
+          <p:nvPr/>
+        </p:nvSpPr>
+        <p:spPr>
+          <a:xfrm>
+            <a:off x="11082528" y="6428232"/>
+            <a:ext cx="530352" cy="256032"/>
+          </a:xfrm>
+          <a:prstGeom prst="rect">
+            <a:avLst/>
+          </a:prstGeom>
+          <a:noFill/>
+        </p:spPr>
+        <p:txBody>
+          <a:bodyPr wrap="square" lIns="0" rIns="0" tIns="0" bIns="0" anchor="t">
+            <a:spAutoFit/>
+          </a:bodyPr>
+          <a:lstStyle/>
+          <a:p>
+            <a:pPr algn="r"/>
+            <a:r>
+              <a:rPr sz="1200" b="1">
+                <a:solidFill>
+                  <a:srgbClr val="6C757D"/>
+                </a:solidFill>
+                <a:latin typeface="Arial"/>
+              </a:rPr>
+              <a:t>07</a:t>
+            </a:r>
+          </a:p>
+        </p:txBody>
+      </p:sp>
+    </p:spTree>
+  </p:cSld>
+  <p:clrMapOvr>
+    <a:masterClrMapping/>
+  </p:clrMapOvr>
+</p:sld>
+</file>
+
+<file path=ppt/slides/slide8.xml><?xml version="1.0" encoding="utf-8"?>
+<p:sld xmlns:a="http://schemas.openxmlformats.org/drawingml/2006/main" xmlns:p="http://schemas.openxmlformats.org/presentationml/2006/main" xmlns:r="http://schemas.openxmlformats.org/officeDocument/2006/relationships">
+  <p:cSld>
+    <p:spTree>
+      <p:nvGrpSpPr>
+        <p:cNvPr id="1" name=""/>
+        <p:cNvGrpSpPr/>
+        <p:nvPr/>
+      </p:nvGrpSpPr>
+      <p:grpSpPr/>
+      <p:sp>
+        <p:nvSpPr>
+          <p:cNvPr id="2" name="Rectangle 1"/>
+          <p:cNvSpPr/>
+          <p:nvPr/>
+        </p:nvSpPr>
+        <p:spPr>
+          <a:xfrm>
+            <a:off x="0" y="0"/>
+            <a:ext cx="12191695" cy="6858000"/>
           </a:xfrm>
           <a:prstGeom prst="rect">
             <a:avLst/>
@@ -7271,6 +8011,205 @@
       </p:sp>
       <p:sp>
         <p:nvSpPr>
+          <p:cNvPr id="3" name="Rectangle 2"/>
+          <p:cNvSpPr/>
+          <p:nvPr/>
+        </p:nvSpPr>
+        <p:spPr>
+          <a:xfrm>
+            <a:off x="0" y="0"/>
+            <a:ext cx="12191695" cy="384048"/>
+          </a:xfrm>
+          <a:prstGeom prst="rect">
+            <a:avLst/>
+          </a:prstGeom>
+          <a:solidFill>
+            <a:srgbClr val="2D6A4F"/>
+          </a:solidFill>
+          <a:ln>
+            <a:noFill/>
+          </a:ln>
+        </p:spPr>
+        <p:style>
+          <a:lnRef idx="1">
+            <a:schemeClr val="accent1"/>
+          </a:lnRef>
+          <a:fillRef idx="3">
+            <a:schemeClr val="accent1"/>
+          </a:fillRef>
+          <a:effectRef idx="2">
+            <a:schemeClr val="accent1"/>
+          </a:effectRef>
+          <a:fontRef idx="minor">
+            <a:schemeClr val="lt1"/>
+          </a:fontRef>
+        </p:style>
+        <p:txBody>
+          <a:bodyPr rtlCol="0" anchor="ctr"/>
+          <a:lstStyle/>
+          <a:p>
+            <a:pPr algn="ctr"/>
+          </a:p>
+        </p:txBody>
+      </p:sp>
+      <p:sp>
+        <p:nvSpPr>
+          <p:cNvPr id="4" name="TextBox 3"/>
+          <p:cNvSpPr txBox="1"/>
+          <p:nvPr/>
+        </p:nvSpPr>
+        <p:spPr>
+          <a:xfrm>
+            <a:off x="566928" y="73152"/>
+            <a:ext cx="6400800" cy="182880"/>
+          </a:xfrm>
+          <a:prstGeom prst="rect">
+            <a:avLst/>
+          </a:prstGeom>
+          <a:noFill/>
+        </p:spPr>
+        <p:txBody>
+          <a:bodyPr wrap="square" lIns="0" rIns="0" tIns="0" bIns="0" anchor="t">
+            <a:spAutoFit/>
+          </a:bodyPr>
+          <a:lstStyle/>
+          <a:p>
+            <a:pPr algn="l"/>
+            <a:r>
+              <a:rPr sz="1000" b="1">
+                <a:solidFill>
+                  <a:srgbClr val="FFFFFF"/>
+                </a:solidFill>
+                <a:latin typeface="Arial"/>
+              </a:rPr>
+              <a:t>04  Conclusion</a:t>
+            </a:r>
+          </a:p>
+        </p:txBody>
+      </p:sp>
+      <p:sp>
+        <p:nvSpPr>
+          <p:cNvPr id="5" name="TextBox 4"/>
+          <p:cNvSpPr txBox="1"/>
+          <p:nvPr/>
+        </p:nvSpPr>
+        <p:spPr>
+          <a:xfrm>
+            <a:off x="566928" y="530352"/>
+            <a:ext cx="10972800" cy="475488"/>
+          </a:xfrm>
+          <a:prstGeom prst="rect">
+            <a:avLst/>
+          </a:prstGeom>
+          <a:noFill/>
+        </p:spPr>
+        <p:txBody>
+          <a:bodyPr wrap="square" lIns="0" rIns="0" tIns="0" bIns="0" anchor="t">
+            <a:spAutoFit/>
+          </a:bodyPr>
+          <a:lstStyle/>
+          <a:p>
+            <a:pPr algn="l"/>
+            <a:r>
+              <a:rPr sz="2500" b="1">
+                <a:solidFill>
+                  <a:srgbClr val="212529"/>
+                </a:solidFill>
+                <a:latin typeface="Arial"/>
+              </a:rPr>
+              <a:t>สรุป: เลือกวิธีวัดผลให้เหมาะกับข้อมูล</a:t>
+            </a:r>
+          </a:p>
+        </p:txBody>
+      </p:sp>
+      <p:sp>
+        <p:nvSpPr>
+          <p:cNvPr id="6" name="Rectangle 5"/>
+          <p:cNvSpPr/>
+          <p:nvPr/>
+        </p:nvSpPr>
+        <p:spPr>
+          <a:xfrm>
+            <a:off x="566928" y="987552"/>
+            <a:ext cx="786384" cy="32004"/>
+          </a:xfrm>
+          <a:prstGeom prst="rect">
+            <a:avLst/>
+          </a:prstGeom>
+          <a:solidFill>
+            <a:srgbClr val="D62828"/>
+          </a:solidFill>
+          <a:ln>
+            <a:noFill/>
+          </a:ln>
+        </p:spPr>
+        <p:style>
+          <a:lnRef idx="1">
+            <a:schemeClr val="accent1"/>
+          </a:lnRef>
+          <a:fillRef idx="3">
+            <a:schemeClr val="accent1"/>
+          </a:fillRef>
+          <a:effectRef idx="2">
+            <a:schemeClr val="accent1"/>
+          </a:effectRef>
+          <a:fontRef idx="minor">
+            <a:schemeClr val="lt1"/>
+          </a:fontRef>
+        </p:style>
+        <p:txBody>
+          <a:bodyPr rtlCol="0" anchor="ctr"/>
+          <a:lstStyle/>
+          <a:p>
+            <a:pPr algn="ctr"/>
+          </a:p>
+        </p:txBody>
+      </p:sp>
+      <p:sp>
+        <p:nvSpPr>
+          <p:cNvPr id="7" name="Rectangle 6"/>
+          <p:cNvSpPr/>
+          <p:nvPr/>
+        </p:nvSpPr>
+        <p:spPr>
+          <a:xfrm>
+            <a:off x="658368" y="1298448"/>
+            <a:ext cx="3401568" cy="3063240"/>
+          </a:xfrm>
+          <a:prstGeom prst="rect">
+            <a:avLst/>
+          </a:prstGeom>
+          <a:solidFill>
+            <a:srgbClr val="F8F9FA"/>
+          </a:solidFill>
+          <a:ln>
+            <a:noFill/>
+          </a:ln>
+        </p:spPr>
+        <p:style>
+          <a:lnRef idx="1">
+            <a:schemeClr val="accent1"/>
+          </a:lnRef>
+          <a:fillRef idx="3">
+            <a:schemeClr val="accent1"/>
+          </a:fillRef>
+          <a:effectRef idx="2">
+            <a:schemeClr val="accent1"/>
+          </a:effectRef>
+          <a:fontRef idx="minor">
+            <a:schemeClr val="lt1"/>
+          </a:fontRef>
+        </p:style>
+        <p:txBody>
+          <a:bodyPr rtlCol="0" anchor="ctr"/>
+          <a:lstStyle/>
+          <a:p>
+            <a:pPr algn="ctr"/>
+          </a:p>
+        </p:txBody>
+      </p:sp>
+      <p:sp>
+        <p:nvSpPr>
           <p:cNvPr id="8" name="Rectangle 7"/>
           <p:cNvSpPr/>
           <p:nvPr/>
@@ -7966,8 +8905,8 @@
         </p:nvSpPr>
         <p:spPr>
           <a:xfrm>
-            <a:off x="11082528" y="6455664"/>
-            <a:ext cx="530352" cy="201168"/>
+            <a:off x="11082528" y="6428232"/>
+            <a:ext cx="530352" cy="256032"/>
           </a:xfrm>
           <a:prstGeom prst="rect">
             <a:avLst/>
@@ -7982,13 +8921,13 @@
           <a:p>
             <a:pPr algn="r"/>
             <a:r>
-              <a:rPr sz="900" b="1">
+              <a:rPr sz="1200" b="1">
                 <a:solidFill>
                   <a:srgbClr val="6C757D"/>
                 </a:solidFill>
                 <a:latin typeface="Arial"/>
               </a:rPr>
-              <a:t>7</a:t>
+              <a:t>08</a:t>
             </a:r>
           </a:p>
         </p:txBody>

</xml_diff>